<commit_message>
updated files for the number 10 presentation
</commit_message>
<xml_diff>
--- a/10/10_eloadas_autentikacio_jogosultsagkezeles.pptx
+++ b/10/10_eloadas_autentikacio_jogosultsagkezeles.pptx
@@ -215,7 +215,7 @@
           <a:p>
             <a:fld id="{4C482E4E-5CEC-44A9-BF2B-512FB3B5604F}" type="datetimeFigureOut">
               <a:rPr lang="en-US" smtClean="0"/>
-              <a:t>1/25/2026</a:t>
+              <a:t>4/20/2026</a:t>
             </a:fld>
             <a:endParaRPr lang="en-US"/>
           </a:p>
@@ -2770,6 +2770,14 @@
             <a:r>
               <a:rPr lang="en-US" dirty="0" err="1"/>
               <a:t>kliensnek</a:t>
+            </a:r>
+            <a:r>
+              <a:rPr lang="hu-HU" dirty="0"/>
+              <a:t> (</a:t>
+            </a:r>
+            <a:r>
+              <a:rPr lang="hu-HU"/>
+              <a:t>klasszikus webalkalmazás)</a:t>
             </a:r>
             <a:r>
               <a:rPr lang="en-US" dirty="0"/>
@@ -8988,7 +8996,7 @@
           <a:p>
             <a:fld id="{E80C50CD-E178-4744-9B35-B2F624D6C5E9}" type="datetimeFigureOut">
               <a:rPr lang="en-US" smtClean="0"/>
-              <a:t>1/25/2026</a:t>
+              <a:t>4/20/2026</a:t>
             </a:fld>
             <a:endParaRPr lang="en-US"/>
           </a:p>
@@ -9186,7 +9194,7 @@
           <a:p>
             <a:fld id="{E80C50CD-E178-4744-9B35-B2F624D6C5E9}" type="datetimeFigureOut">
               <a:rPr lang="en-US" smtClean="0"/>
-              <a:t>1/25/2026</a:t>
+              <a:t>4/20/2026</a:t>
             </a:fld>
             <a:endParaRPr lang="en-US"/>
           </a:p>
@@ -9394,7 +9402,7 @@
           <a:p>
             <a:fld id="{E80C50CD-E178-4744-9B35-B2F624D6C5E9}" type="datetimeFigureOut">
               <a:rPr lang="en-US" smtClean="0"/>
-              <a:t>1/25/2026</a:t>
+              <a:t>4/20/2026</a:t>
             </a:fld>
             <a:endParaRPr lang="en-US"/>
           </a:p>
@@ -9644,7 +9652,7 @@
           <a:p>
             <a:fld id="{E80C50CD-E178-4744-9B35-B2F624D6C5E9}" type="datetimeFigureOut">
               <a:rPr lang="en-US" smtClean="0"/>
-              <a:t>1/25/2026</a:t>
+              <a:t>4/20/2026</a:t>
             </a:fld>
             <a:endParaRPr lang="en-US"/>
           </a:p>
@@ -9923,7 +9931,7 @@
           <a:p>
             <a:fld id="{E80C50CD-E178-4744-9B35-B2F624D6C5E9}" type="datetimeFigureOut">
               <a:rPr lang="en-US" smtClean="0"/>
-              <a:t>1/25/2026</a:t>
+              <a:t>4/20/2026</a:t>
             </a:fld>
             <a:endParaRPr lang="en-US"/>
           </a:p>
@@ -10240,7 +10248,7 @@
           <a:p>
             <a:fld id="{E80C50CD-E178-4744-9B35-B2F624D6C5E9}" type="datetimeFigureOut">
               <a:rPr lang="en-US" smtClean="0"/>
-              <a:t>1/25/2026</a:t>
+              <a:t>4/20/2026</a:t>
             </a:fld>
             <a:endParaRPr lang="en-US"/>
           </a:p>
@@ -10656,7 +10664,7 @@
           <a:p>
             <a:fld id="{E80C50CD-E178-4744-9B35-B2F624D6C5E9}" type="datetimeFigureOut">
               <a:rPr lang="en-US" smtClean="0"/>
-              <a:t>1/25/2026</a:t>
+              <a:t>4/20/2026</a:t>
             </a:fld>
             <a:endParaRPr lang="en-US"/>
           </a:p>
@@ -10797,7 +10805,7 @@
           <a:p>
             <a:fld id="{E80C50CD-E178-4744-9B35-B2F624D6C5E9}" type="datetimeFigureOut">
               <a:rPr lang="en-US" smtClean="0"/>
-              <a:t>1/25/2026</a:t>
+              <a:t>4/20/2026</a:t>
             </a:fld>
             <a:endParaRPr lang="en-US"/>
           </a:p>
@@ -10910,7 +10918,7 @@
           <a:p>
             <a:fld id="{E80C50CD-E178-4744-9B35-B2F624D6C5E9}" type="datetimeFigureOut">
               <a:rPr lang="en-US" smtClean="0"/>
-              <a:t>1/25/2026</a:t>
+              <a:t>4/20/2026</a:t>
             </a:fld>
             <a:endParaRPr lang="en-US"/>
           </a:p>
@@ -11227,7 +11235,7 @@
           <a:p>
             <a:fld id="{E80C50CD-E178-4744-9B35-B2F624D6C5E9}" type="datetimeFigureOut">
               <a:rPr lang="en-US" smtClean="0"/>
-              <a:t>1/25/2026</a:t>
+              <a:t>4/20/2026</a:t>
             </a:fld>
             <a:endParaRPr lang="en-US"/>
           </a:p>
@@ -11519,7 +11527,7 @@
           <a:p>
             <a:fld id="{E80C50CD-E178-4744-9B35-B2F624D6C5E9}" type="datetimeFigureOut">
               <a:rPr lang="en-US" smtClean="0"/>
-              <a:t>1/25/2026</a:t>
+              <a:t>4/20/2026</a:t>
             </a:fld>
             <a:endParaRPr lang="en-US"/>
           </a:p>
@@ -11759,7 +11767,7 @@
             <a:fld id="{E80C50CD-E178-4744-9B35-B2F624D6C5E9}" type="datetimeFigureOut">
               <a:rPr lang="en-US" smtClean="0"/>
               <a:pPr/>
-              <a:t>1/25/2026</a:t>
+              <a:t>4/20/2026</a:t>
             </a:fld>
             <a:endParaRPr lang="en-US"/>
           </a:p>

</xml_diff>